<commit_message>
Implement KPI report export functionality and update assets
Replit-Commit-Author: Agent
</commit_message>
<xml_diff>
--- a/attached_assets/kpi_business_metrics_template.pptx
+++ b/attached_assets/kpi_business_metrics_template.pptx
@@ -1615,8 +1615,8 @@
         </p:nvSpPr>
         <p:spPr>
           <a:xfrm>
-            <a:off x="429768" y="1783080"/>
-            <a:ext cx="3108960" cy="164592"/>
+            <a:off x="6492240" y="1472184"/>
+            <a:ext cx="4937760" cy="155448"/>
           </a:xfrm>
           <a:prstGeom prst="rect">
             <a:avLst/>
@@ -1630,21 +1630,21 @@
           </a:bodyPr>
           <a:lstStyle/>
           <a:p>
-            <a:pPr indent="0" marL="0">
-              <a:buNone/>
-            </a:pPr>
-            <a:r>
-              <a:rPr lang="en-US" sz="910" b="1" dirty="0">
-                <a:solidFill>
-                  <a:srgbClr val="303030"/>
-                </a:solidFill>
-                <a:latin typeface="Arial" pitchFamily="34" charset="0"/>
-                <a:ea typeface="Arial" pitchFamily="34" charset="-122"/>
-                <a:cs typeface="Arial" pitchFamily="34" charset="-120"/>
-              </a:rPr>
-              <a:t>Budget / Revenue:</a:t>
-            </a:r>
-            <a:endParaRPr lang="en-US" sz="910" dirty="0"/>
+            <a:pPr algn="r" indent="0" marL="0">
+              <a:buNone/>
+            </a:pPr>
+            <a:r>
+              <a:rPr lang="en-US" sz="700" b="1" dirty="0">
+                <a:solidFill>
+                  <a:srgbClr val="626262"/>
+                </a:solidFill>
+                <a:latin typeface="Arial" pitchFamily="34" charset="0"/>
+                <a:ea typeface="Arial" pitchFamily="34" charset="-122"/>
+                <a:cs typeface="Arial" pitchFamily="34" charset="-120"/>
+              </a:rPr>
+              <a:t>Green: current plan-excel scope  •  Red: Phase 2 / out of scope</a:t>
+            </a:r>
+            <a:endParaRPr lang="en-US" sz="700" dirty="0"/>
           </a:p>
         </p:txBody>
       </p:sp>
@@ -1656,8 +1656,8 @@
         </p:nvSpPr>
         <p:spPr>
           <a:xfrm>
-            <a:off x="566928" y="1984248"/>
-            <a:ext cx="10972800" cy="594360"/>
+            <a:off x="429768" y="1783080"/>
+            <a:ext cx="3108960" cy="164592"/>
           </a:xfrm>
           <a:prstGeom prst="rect">
             <a:avLst/>
@@ -1675,34 +1675,17 @@
               <a:buNone/>
             </a:pPr>
             <a:r>
-              <a:rPr lang="en-US" sz="760" dirty="0">
-                <a:solidFill>
-                  <a:srgbClr val="303030"/>
-                </a:solidFill>
-                <a:latin typeface="Arial" pitchFamily="34" charset="0"/>
-                <a:ea typeface="Arial" pitchFamily="34" charset="-122"/>
-                <a:cs typeface="Arial" pitchFamily="34" charset="-120"/>
-              </a:rPr>
-              <a:t>{{budget_revenue_summary}}</a:t>
-            </a:r>
-            <a:endParaRPr lang="en-US" sz="760" dirty="0"/>
-          </a:p>
-          <a:p>
-            <a:pPr indent="0" marL="0">
-              <a:buNone/>
-            </a:pPr>
-            <a:r>
-              <a:rPr lang="en-US" sz="760" dirty="0">
-                <a:solidFill>
-                  <a:srgbClr val="303030"/>
-                </a:solidFill>
-                <a:latin typeface="Arial" pitchFamily="34" charset="0"/>
-                <a:ea typeface="Arial" pitchFamily="34" charset="-122"/>
-                <a:cs typeface="Arial" pitchFamily="34" charset="-120"/>
-              </a:rPr>
-              <a:t>Actual: {{budget_revenue_actual}} | Forecast: {{budget_revenue_forecast}} | Variance: {{budget_revenue_variance}}</a:t>
-            </a:r>
-            <a:endParaRPr lang="en-US" sz="760" dirty="0"/>
+              <a:rPr lang="en-US" sz="910" b="1" dirty="0">
+                <a:solidFill>
+                  <a:srgbClr val="009B76"/>
+                </a:solidFill>
+                <a:latin typeface="Arial" pitchFamily="34" charset="0"/>
+                <a:ea typeface="Arial" pitchFamily="34" charset="-122"/>
+                <a:cs typeface="Arial" pitchFamily="34" charset="-120"/>
+              </a:rPr>
+              <a:t>Budget / Revenue:</a:t>
+            </a:r>
+            <a:endParaRPr lang="en-US" sz="910" dirty="0"/>
           </a:p>
         </p:txBody>
       </p:sp>
@@ -1714,8 +1697,8 @@
         </p:nvSpPr>
         <p:spPr>
           <a:xfrm>
-            <a:off x="429768" y="2542032"/>
-            <a:ext cx="3108960" cy="164592"/>
+            <a:off x="566928" y="1984248"/>
+            <a:ext cx="10972800" cy="594360"/>
           </a:xfrm>
           <a:prstGeom prst="rect">
             <a:avLst/>
@@ -1733,17 +1716,34 @@
               <a:buNone/>
             </a:pPr>
             <a:r>
-              <a:rPr lang="en-US" sz="910" b="1" dirty="0">
-                <a:solidFill>
-                  <a:srgbClr val="303030"/>
-                </a:solidFill>
-                <a:latin typeface="Arial" pitchFamily="34" charset="0"/>
-                <a:ea typeface="Arial" pitchFamily="34" charset="-122"/>
-                <a:cs typeface="Arial" pitchFamily="34" charset="-120"/>
-              </a:rPr>
-              <a:t>Internal Utilization:</a:t>
-            </a:r>
-            <a:endParaRPr lang="en-US" sz="910" dirty="0"/>
+              <a:rPr lang="en-US" sz="720" dirty="0">
+                <a:solidFill>
+                  <a:srgbClr val="009B76"/>
+                </a:solidFill>
+                <a:latin typeface="Arial" pitchFamily="34" charset="0"/>
+                <a:ea typeface="Arial" pitchFamily="34" charset="-122"/>
+                <a:cs typeface="Arial" pitchFamily="34" charset="-120"/>
+              </a:rPr>
+              <a:t>{{budget_revenue_summary}}</a:t>
+            </a:r>
+            <a:endParaRPr lang="en-US" sz="720" dirty="0"/>
+          </a:p>
+          <a:p>
+            <a:pPr indent="0" marL="0">
+              <a:buNone/>
+            </a:pPr>
+            <a:r>
+              <a:rPr lang="en-US" sz="720" dirty="0">
+                <a:solidFill>
+                  <a:srgbClr val="009B76"/>
+                </a:solidFill>
+                <a:latin typeface="Arial" pitchFamily="34" charset="0"/>
+                <a:ea typeface="Arial" pitchFamily="34" charset="-122"/>
+                <a:cs typeface="Arial" pitchFamily="34" charset="-120"/>
+              </a:rPr>
+              <a:t>{{budget_revenue_scope_lines}}</a:t>
+            </a:r>
+            <a:endParaRPr lang="en-US" sz="720" dirty="0"/>
           </a:p>
         </p:txBody>
       </p:sp>
@@ -1755,8 +1755,8 @@
         </p:nvSpPr>
         <p:spPr>
           <a:xfrm>
-            <a:off x="566928" y="2743200"/>
-            <a:ext cx="10972800" cy="539496"/>
+            <a:off x="429768" y="2542032"/>
+            <a:ext cx="3108960" cy="164592"/>
           </a:xfrm>
           <a:prstGeom prst="rect">
             <a:avLst/>
@@ -1774,34 +1774,17 @@
               <a:buNone/>
             </a:pPr>
             <a:r>
-              <a:rPr lang="en-US" sz="760" dirty="0">
-                <a:solidFill>
-                  <a:srgbClr val="303030"/>
-                </a:solidFill>
-                <a:latin typeface="Arial" pitchFamily="34" charset="0"/>
-                <a:ea typeface="Arial" pitchFamily="34" charset="-122"/>
-                <a:cs typeface="Arial" pitchFamily="34" charset="-120"/>
-              </a:rPr>
-              <a:t>{{internal_utilization_summary}}</a:t>
-            </a:r>
-            <a:endParaRPr lang="en-US" sz="760" dirty="0"/>
-          </a:p>
-          <a:p>
-            <a:pPr indent="0" marL="0">
-              <a:buNone/>
-            </a:pPr>
-            <a:r>
-              <a:rPr lang="en-US" sz="760" dirty="0">
-                <a:solidFill>
-                  <a:srgbClr val="303030"/>
-                </a:solidFill>
-                <a:latin typeface="Arial" pitchFamily="34" charset="0"/>
-                <a:ea typeface="Arial" pitchFamily="34" charset="-122"/>
-                <a:cs typeface="Arial" pitchFamily="34" charset="-120"/>
-              </a:rPr>
-              <a:t>Actual: {{internal_utilization_actual}} | Forecast: {{internal_utilization_forecast}} | Variance: {{internal_utilization_variance}}</a:t>
-            </a:r>
-            <a:endParaRPr lang="en-US" sz="760" dirty="0"/>
+              <a:rPr lang="en-US" sz="910" b="1" dirty="0">
+                <a:solidFill>
+                  <a:srgbClr val="009B76"/>
+                </a:solidFill>
+                <a:latin typeface="Arial" pitchFamily="34" charset="0"/>
+                <a:ea typeface="Arial" pitchFamily="34" charset="-122"/>
+                <a:cs typeface="Arial" pitchFamily="34" charset="-120"/>
+              </a:rPr>
+              <a:t>Internal Utilization:</a:t>
+            </a:r>
+            <a:endParaRPr lang="en-US" sz="910" dirty="0"/>
           </a:p>
         </p:txBody>
       </p:sp>
@@ -1813,8 +1796,8 @@
         </p:nvSpPr>
         <p:spPr>
           <a:xfrm>
-            <a:off x="429768" y="3246120"/>
-            <a:ext cx="3108960" cy="164592"/>
+            <a:off x="566928" y="2743200"/>
+            <a:ext cx="10972800" cy="539496"/>
           </a:xfrm>
           <a:prstGeom prst="rect">
             <a:avLst/>
@@ -1832,17 +1815,34 @@
               <a:buNone/>
             </a:pPr>
             <a:r>
-              <a:rPr lang="en-US" sz="910" b="1" dirty="0">
-                <a:solidFill>
-                  <a:srgbClr val="303030"/>
-                </a:solidFill>
-                <a:latin typeface="Arial" pitchFamily="34" charset="0"/>
-                <a:ea typeface="Arial" pitchFamily="34" charset="-122"/>
-                <a:cs typeface="Arial" pitchFamily="34" charset="-120"/>
-              </a:rPr>
-              <a:t>External Utilization:</a:t>
-            </a:r>
-            <a:endParaRPr lang="en-US" sz="910" dirty="0"/>
+              <a:rPr lang="en-US" sz="720" dirty="0">
+                <a:solidFill>
+                  <a:srgbClr val="009B76"/>
+                </a:solidFill>
+                <a:latin typeface="Arial" pitchFamily="34" charset="0"/>
+                <a:ea typeface="Arial" pitchFamily="34" charset="-122"/>
+                <a:cs typeface="Arial" pitchFamily="34" charset="-120"/>
+              </a:rPr>
+              <a:t>{{internal_utilization_summary}}</a:t>
+            </a:r>
+            <a:endParaRPr lang="en-US" sz="720" dirty="0"/>
+          </a:p>
+          <a:p>
+            <a:pPr indent="0" marL="0">
+              <a:buNone/>
+            </a:pPr>
+            <a:r>
+              <a:rPr lang="en-US" sz="720" dirty="0">
+                <a:solidFill>
+                  <a:srgbClr val="009B76"/>
+                </a:solidFill>
+                <a:latin typeface="Arial" pitchFamily="34" charset="0"/>
+                <a:ea typeface="Arial" pitchFamily="34" charset="-122"/>
+                <a:cs typeface="Arial" pitchFamily="34" charset="-120"/>
+              </a:rPr>
+              <a:t>{{internal_utilization_scope_lines}}</a:t>
+            </a:r>
+            <a:endParaRPr lang="en-US" sz="720" dirty="0"/>
           </a:p>
         </p:txBody>
       </p:sp>
@@ -1854,8 +1854,8 @@
         </p:nvSpPr>
         <p:spPr>
           <a:xfrm>
-            <a:off x="566928" y="3447288"/>
-            <a:ext cx="10972800" cy="539496"/>
+            <a:off x="429768" y="3246120"/>
+            <a:ext cx="3108960" cy="164592"/>
           </a:xfrm>
           <a:prstGeom prst="rect">
             <a:avLst/>
@@ -1873,34 +1873,17 @@
               <a:buNone/>
             </a:pPr>
             <a:r>
-              <a:rPr lang="en-US" sz="760" dirty="0">
-                <a:solidFill>
-                  <a:srgbClr val="303030"/>
-                </a:solidFill>
-                <a:latin typeface="Arial" pitchFamily="34" charset="0"/>
-                <a:ea typeface="Arial" pitchFamily="34" charset="-122"/>
-                <a:cs typeface="Arial" pitchFamily="34" charset="-120"/>
-              </a:rPr>
-              <a:t>{{external_utilization_summary}}</a:t>
-            </a:r>
-            <a:endParaRPr lang="en-US" sz="760" dirty="0"/>
-          </a:p>
-          <a:p>
-            <a:pPr indent="0" marL="0">
-              <a:buNone/>
-            </a:pPr>
-            <a:r>
-              <a:rPr lang="en-US" sz="760" dirty="0">
-                <a:solidFill>
-                  <a:srgbClr val="303030"/>
-                </a:solidFill>
-                <a:latin typeface="Arial" pitchFamily="34" charset="0"/>
-                <a:ea typeface="Arial" pitchFamily="34" charset="-122"/>
-                <a:cs typeface="Arial" pitchFamily="34" charset="-120"/>
-              </a:rPr>
-              <a:t>Actual: {{external_utilization_actual}} | Forecast: {{external_utilization_forecast}} | Variance: {{external_utilization_variance}}</a:t>
-            </a:r>
-            <a:endParaRPr lang="en-US" sz="760" dirty="0"/>
+              <a:rPr lang="en-US" sz="910" b="1" dirty="0">
+                <a:solidFill>
+                  <a:srgbClr val="009B76"/>
+                </a:solidFill>
+                <a:latin typeface="Arial" pitchFamily="34" charset="0"/>
+                <a:ea typeface="Arial" pitchFamily="34" charset="-122"/>
+                <a:cs typeface="Arial" pitchFamily="34" charset="-120"/>
+              </a:rPr>
+              <a:t>External Utilization:</a:t>
+            </a:r>
+            <a:endParaRPr lang="en-US" sz="910" dirty="0"/>
           </a:p>
         </p:txBody>
       </p:sp>
@@ -1912,8 +1895,8 @@
         </p:nvSpPr>
         <p:spPr>
           <a:xfrm>
-            <a:off x="429768" y="3950208"/>
-            <a:ext cx="3108960" cy="164592"/>
+            <a:off x="566928" y="3447288"/>
+            <a:ext cx="10972800" cy="539496"/>
           </a:xfrm>
           <a:prstGeom prst="rect">
             <a:avLst/>
@@ -1931,17 +1914,34 @@
               <a:buNone/>
             </a:pPr>
             <a:r>
-              <a:rPr lang="en-US" sz="910" b="1" dirty="0">
-                <a:solidFill>
-                  <a:srgbClr val="303030"/>
-                </a:solidFill>
-                <a:latin typeface="Arial" pitchFamily="34" charset="0"/>
-                <a:ea typeface="Arial" pitchFamily="34" charset="-122"/>
-                <a:cs typeface="Arial" pitchFamily="34" charset="-120"/>
-              </a:rPr>
-              <a:t>Capacity (Internal + External):</a:t>
-            </a:r>
-            <a:endParaRPr lang="en-US" sz="910" dirty="0"/>
+              <a:rPr lang="en-US" sz="720" dirty="0">
+                <a:solidFill>
+                  <a:srgbClr val="009B76"/>
+                </a:solidFill>
+                <a:latin typeface="Arial" pitchFamily="34" charset="0"/>
+                <a:ea typeface="Arial" pitchFamily="34" charset="-122"/>
+                <a:cs typeface="Arial" pitchFamily="34" charset="-120"/>
+              </a:rPr>
+              <a:t>{{external_utilization_summary}}</a:t>
+            </a:r>
+            <a:endParaRPr lang="en-US" sz="720" dirty="0"/>
+          </a:p>
+          <a:p>
+            <a:pPr indent="0" marL="0">
+              <a:buNone/>
+            </a:pPr>
+            <a:r>
+              <a:rPr lang="en-US" sz="720" dirty="0">
+                <a:solidFill>
+                  <a:srgbClr val="009B76"/>
+                </a:solidFill>
+                <a:latin typeface="Arial" pitchFamily="34" charset="0"/>
+                <a:ea typeface="Arial" pitchFamily="34" charset="-122"/>
+                <a:cs typeface="Arial" pitchFamily="34" charset="-120"/>
+              </a:rPr>
+              <a:t>{{external_utilization_scope_lines}}</a:t>
+            </a:r>
+            <a:endParaRPr lang="en-US" sz="720" dirty="0"/>
           </a:p>
         </p:txBody>
       </p:sp>
@@ -1953,8 +1953,8 @@
         </p:nvSpPr>
         <p:spPr>
           <a:xfrm>
-            <a:off x="566928" y="4151376"/>
-            <a:ext cx="10972800" cy="539496"/>
+            <a:off x="429768" y="3950208"/>
+            <a:ext cx="3108960" cy="164592"/>
           </a:xfrm>
           <a:prstGeom prst="rect">
             <a:avLst/>
@@ -1972,34 +1972,17 @@
               <a:buNone/>
             </a:pPr>
             <a:r>
-              <a:rPr lang="en-US" sz="760" dirty="0">
-                <a:solidFill>
-                  <a:srgbClr val="303030"/>
-                </a:solidFill>
-                <a:latin typeface="Arial" pitchFamily="34" charset="0"/>
-                <a:ea typeface="Arial" pitchFamily="34" charset="-122"/>
-                <a:cs typeface="Arial" pitchFamily="34" charset="-120"/>
-              </a:rPr>
-              <a:t>{{capacity_summary}}</a:t>
-            </a:r>
-            <a:endParaRPr lang="en-US" sz="760" dirty="0"/>
-          </a:p>
-          <a:p>
-            <a:pPr indent="0" marL="0">
-              <a:buNone/>
-            </a:pPr>
-            <a:r>
-              <a:rPr lang="en-US" sz="760" dirty="0">
-                <a:solidFill>
-                  <a:srgbClr val="303030"/>
-                </a:solidFill>
-                <a:latin typeface="Arial" pitchFamily="34" charset="0"/>
-                <a:ea typeface="Arial" pitchFamily="34" charset="-122"/>
-                <a:cs typeface="Arial" pitchFamily="34" charset="-120"/>
-              </a:rPr>
-              <a:t>Actual: {{capacity_actual}} | Forecast: {{capacity_forecast}} | Variance: {{capacity_variance}}</a:t>
-            </a:r>
-            <a:endParaRPr lang="en-US" sz="760" dirty="0"/>
+              <a:rPr lang="en-US" sz="910" b="1" dirty="0">
+                <a:solidFill>
+                  <a:srgbClr val="009B76"/>
+                </a:solidFill>
+                <a:latin typeface="Arial" pitchFamily="34" charset="0"/>
+                <a:ea typeface="Arial" pitchFamily="34" charset="-122"/>
+                <a:cs typeface="Arial" pitchFamily="34" charset="-120"/>
+              </a:rPr>
+              <a:t>Capacity (Internal + External):</a:t>
+            </a:r>
+            <a:endParaRPr lang="en-US" sz="910" dirty="0"/>
           </a:p>
         </p:txBody>
       </p:sp>
@@ -2011,8 +1994,8 @@
         </p:nvSpPr>
         <p:spPr>
           <a:xfrm>
-            <a:off x="429768" y="4654296"/>
-            <a:ext cx="3108960" cy="164592"/>
+            <a:off x="566928" y="4151376"/>
+            <a:ext cx="10972800" cy="539496"/>
           </a:xfrm>
           <a:prstGeom prst="rect">
             <a:avLst/>
@@ -2030,17 +2013,34 @@
               <a:buNone/>
             </a:pPr>
             <a:r>
-              <a:rPr lang="en-US" sz="910" b="1" dirty="0">
-                <a:solidFill>
-                  <a:srgbClr val="303030"/>
-                </a:solidFill>
-                <a:latin typeface="Arial" pitchFamily="34" charset="0"/>
-                <a:ea typeface="Arial" pitchFamily="34" charset="-122"/>
-                <a:cs typeface="Arial" pitchFamily="34" charset="-120"/>
-              </a:rPr>
-              <a:t>EBIT:</a:t>
-            </a:r>
-            <a:endParaRPr lang="en-US" sz="910" dirty="0"/>
+              <a:rPr lang="en-US" sz="720" dirty="0">
+                <a:solidFill>
+                  <a:srgbClr val="009B76"/>
+                </a:solidFill>
+                <a:latin typeface="Arial" pitchFamily="34" charset="0"/>
+                <a:ea typeface="Arial" pitchFamily="34" charset="-122"/>
+                <a:cs typeface="Arial" pitchFamily="34" charset="-120"/>
+              </a:rPr>
+              <a:t>{{capacity_summary}}</a:t>
+            </a:r>
+            <a:endParaRPr lang="en-US" sz="720" dirty="0"/>
+          </a:p>
+          <a:p>
+            <a:pPr indent="0" marL="0">
+              <a:buNone/>
+            </a:pPr>
+            <a:r>
+              <a:rPr lang="en-US" sz="720" dirty="0">
+                <a:solidFill>
+                  <a:srgbClr val="009B76"/>
+                </a:solidFill>
+                <a:latin typeface="Arial" pitchFamily="34" charset="0"/>
+                <a:ea typeface="Arial" pitchFamily="34" charset="-122"/>
+                <a:cs typeface="Arial" pitchFamily="34" charset="-120"/>
+              </a:rPr>
+              <a:t>{{capacity_scope_lines}}</a:t>
+            </a:r>
+            <a:endParaRPr lang="en-US" sz="720" dirty="0"/>
           </a:p>
         </p:txBody>
       </p:sp>
@@ -2052,8 +2052,8 @@
         </p:nvSpPr>
         <p:spPr>
           <a:xfrm>
-            <a:off x="566928" y="4855464"/>
-            <a:ext cx="10972800" cy="457200"/>
+            <a:off x="429768" y="4654296"/>
+            <a:ext cx="3108960" cy="164592"/>
           </a:xfrm>
           <a:prstGeom prst="rect">
             <a:avLst/>
@@ -2071,23 +2071,146 @@
               <a:buNone/>
             </a:pPr>
             <a:r>
-              <a:rPr lang="en-US" sz="760" dirty="0">
-                <a:solidFill>
-                  <a:srgbClr val="303030"/>
-                </a:solidFill>
-                <a:latin typeface="Arial" pitchFamily="34" charset="0"/>
-                <a:ea typeface="Arial" pitchFamily="34" charset="-122"/>
-                <a:cs typeface="Arial" pitchFamily="34" charset="-120"/>
-              </a:rPr>
-              <a:t>{{ebit_commentary_or_risk}}</a:t>
-            </a:r>
-            <a:endParaRPr lang="en-US" sz="760" dirty="0"/>
-          </a:p>
-        </p:txBody>
-      </p:sp>
-      <p:sp>
-        <p:nvSpPr>
-          <p:cNvPr id="33" name="Shape 31"/>
+              <a:rPr lang="en-US" sz="910" b="1" dirty="0">
+                <a:solidFill>
+                  <a:srgbClr val="D9192B"/>
+                </a:solidFill>
+                <a:latin typeface="Arial" pitchFamily="34" charset="0"/>
+                <a:ea typeface="Arial" pitchFamily="34" charset="-122"/>
+                <a:cs typeface="Arial" pitchFamily="34" charset="-120"/>
+              </a:rPr>
+              <a:t>EBIT:</a:t>
+            </a:r>
+            <a:endParaRPr lang="en-US" sz="910" dirty="0"/>
+          </a:p>
+        </p:txBody>
+      </p:sp>
+      <p:sp>
+        <p:nvSpPr>
+          <p:cNvPr id="33" name="Text 31"/>
+          <p:cNvSpPr/>
+          <p:nvPr/>
+        </p:nvSpPr>
+        <p:spPr>
+          <a:xfrm>
+            <a:off x="566928" y="4855464"/>
+            <a:ext cx="10972800" cy="365760"/>
+          </a:xfrm>
+          <a:prstGeom prst="rect">
+            <a:avLst/>
+          </a:prstGeom>
+          <a:noFill/>
+          <a:ln/>
+        </p:spPr>
+        <p:txBody>
+          <a:bodyPr wrap="square" lIns="0" tIns="0" rIns="0" bIns="0" rtlCol="0" anchor="t">
+            <a:normAutofit/>
+          </a:bodyPr>
+          <a:lstStyle/>
+          <a:p>
+            <a:pPr indent="0" marL="0">
+              <a:buNone/>
+            </a:pPr>
+            <a:r>
+              <a:rPr lang="en-US" sz="720" dirty="0">
+                <a:solidFill>
+                  <a:srgbClr val="D9192B"/>
+                </a:solidFill>
+                <a:latin typeface="Arial" pitchFamily="34" charset="0"/>
+                <a:ea typeface="Arial" pitchFamily="34" charset="-122"/>
+                <a:cs typeface="Arial" pitchFamily="34" charset="-120"/>
+              </a:rPr>
+              <a:t>{{ebit_phase_2_scope_note}}</a:t>
+            </a:r>
+            <a:endParaRPr lang="en-US" sz="720" dirty="0"/>
+          </a:p>
+        </p:txBody>
+      </p:sp>
+      <p:sp>
+        <p:nvSpPr>
+          <p:cNvPr id="34" name="Text 32"/>
+          <p:cNvSpPr/>
+          <p:nvPr/>
+        </p:nvSpPr>
+        <p:spPr>
+          <a:xfrm>
+            <a:off x="429768" y="5184648"/>
+            <a:ext cx="3108960" cy="164592"/>
+          </a:xfrm>
+          <a:prstGeom prst="rect">
+            <a:avLst/>
+          </a:prstGeom>
+          <a:noFill/>
+          <a:ln/>
+        </p:spPr>
+        <p:txBody>
+          <a:bodyPr wrap="square" lIns="0" tIns="0" rIns="0" bIns="0" rtlCol="0" anchor="t">
+            <a:normAutofit/>
+          </a:bodyPr>
+          <a:lstStyle/>
+          <a:p>
+            <a:pPr indent="0" marL="0">
+              <a:buNone/>
+            </a:pPr>
+            <a:r>
+              <a:rPr lang="en-US" sz="910" b="1" dirty="0">
+                <a:solidFill>
+                  <a:srgbClr val="D9192B"/>
+                </a:solidFill>
+                <a:latin typeface="Arial" pitchFamily="34" charset="0"/>
+                <a:ea typeface="Arial" pitchFamily="34" charset="-122"/>
+                <a:cs typeface="Arial" pitchFamily="34" charset="-120"/>
+              </a:rPr>
+              <a:t>Capex:</a:t>
+            </a:r>
+            <a:endParaRPr lang="en-US" sz="910" dirty="0"/>
+          </a:p>
+        </p:txBody>
+      </p:sp>
+      <p:sp>
+        <p:nvSpPr>
+          <p:cNvPr id="35" name="Text 33"/>
+          <p:cNvSpPr/>
+          <p:nvPr/>
+        </p:nvSpPr>
+        <p:spPr>
+          <a:xfrm>
+            <a:off x="566928" y="5385816"/>
+            <a:ext cx="10972800" cy="274320"/>
+          </a:xfrm>
+          <a:prstGeom prst="rect">
+            <a:avLst/>
+          </a:prstGeom>
+          <a:noFill/>
+          <a:ln/>
+        </p:spPr>
+        <p:txBody>
+          <a:bodyPr wrap="square" lIns="0" tIns="0" rIns="0" bIns="0" rtlCol="0" anchor="t">
+            <a:normAutofit/>
+          </a:bodyPr>
+          <a:lstStyle/>
+          <a:p>
+            <a:pPr indent="0" marL="0">
+              <a:buNone/>
+            </a:pPr>
+            <a:r>
+              <a:rPr lang="en-US" sz="720" dirty="0">
+                <a:solidFill>
+                  <a:srgbClr val="D9192B"/>
+                </a:solidFill>
+                <a:latin typeface="Arial" pitchFamily="34" charset="0"/>
+                <a:ea typeface="Arial" pitchFamily="34" charset="-122"/>
+                <a:cs typeface="Arial" pitchFamily="34" charset="-120"/>
+              </a:rPr>
+              <a:t>{{capex_phase_2_scope_note}}</a:t>
+            </a:r>
+            <a:endParaRPr lang="en-US" sz="720" dirty="0"/>
+          </a:p>
+        </p:txBody>
+      </p:sp>
+      <p:sp>
+        <p:nvSpPr>
+          <p:cNvPr id="36" name="Shape 34"/>
           <p:cNvSpPr/>
           <p:nvPr/>
         </p:nvSpPr>
@@ -2110,7 +2233,7 @@
       </p:sp>
       <p:sp>
         <p:nvSpPr>
-          <p:cNvPr id="34" name="Text 32"/>
+          <p:cNvPr id="37" name="Text 35"/>
           <p:cNvSpPr/>
           <p:nvPr/>
         </p:nvSpPr>
@@ -2151,7 +2274,7 @@
       </p:sp>
       <p:sp>
         <p:nvSpPr>
-          <p:cNvPr id="35" name="Text 33"/>
+          <p:cNvPr id="38" name="Text 36"/>
           <p:cNvSpPr/>
           <p:nvPr/>
         </p:nvSpPr>
@@ -2192,7 +2315,7 @@
       </p:sp>
       <p:sp>
         <p:nvSpPr>
-          <p:cNvPr id="36" name="Text 34"/>
+          <p:cNvPr id="39" name="Text 37"/>
           <p:cNvSpPr/>
           <p:nvPr/>
         </p:nvSpPr>
@@ -2233,7 +2356,7 @@
       </p:sp>
       <p:sp>
         <p:nvSpPr>
-          <p:cNvPr id="37" name="Shape 35"/>
+          <p:cNvPr id="40" name="Shape 38"/>
           <p:cNvSpPr/>
           <p:nvPr/>
         </p:nvSpPr>
@@ -2260,7 +2383,7 @@
       </p:sp>
       <p:sp>
         <p:nvSpPr>
-          <p:cNvPr id="38" name="Shape 36"/>
+          <p:cNvPr id="41" name="Shape 39"/>
           <p:cNvSpPr/>
           <p:nvPr/>
         </p:nvSpPr>
@@ -2287,7 +2410,7 @@
       </p:sp>
       <p:sp>
         <p:nvSpPr>
-          <p:cNvPr id="39" name="Shape 37"/>
+          <p:cNvPr id="42" name="Shape 40"/>
           <p:cNvSpPr/>
           <p:nvPr/>
         </p:nvSpPr>
@@ -2314,7 +2437,7 @@
       </p:sp>
       <p:sp>
         <p:nvSpPr>
-          <p:cNvPr id="40" name="Shape 38"/>
+          <p:cNvPr id="43" name="Shape 41"/>
           <p:cNvSpPr/>
           <p:nvPr/>
         </p:nvSpPr>
@@ -2341,7 +2464,7 @@
       </p:sp>
       <p:sp>
         <p:nvSpPr>
-          <p:cNvPr id="41" name="Text 39"/>
+          <p:cNvPr id="44" name="Text 42"/>
           <p:cNvSpPr/>
           <p:nvPr/>
         </p:nvSpPr>
@@ -2382,7 +2505,7 @@
       </p:sp>
       <p:sp>
         <p:nvSpPr>
-          <p:cNvPr id="42" name="Text 40"/>
+          <p:cNvPr id="45" name="Text 43"/>
           <p:cNvSpPr/>
           <p:nvPr/>
         </p:nvSpPr>

</xml_diff>